<commit_message>
Fixed the windows sizing issue when exiting the full screen and changed presentation.
</commit_message>
<xml_diff>
--- a/Presentation/Capstone-Presentation.pptx
+++ b/Presentation/Capstone-Presentation.pptx
@@ -47,7 +47,7 @@
         <p:spPr>
           <a:xfrm>
             <a:off x="0" y="0"/>
-            <a:ext cx="10079640" cy="5669640"/>
+            <a:ext cx="10079280" cy="5669280"/>
           </a:xfrm>
           <a:prstGeom prst="rect">
             <a:avLst/>
@@ -102,7 +102,7 @@
         <p:spPr>
           <a:xfrm>
             <a:off x="540000" y="1440000"/>
-            <a:ext cx="8999640" cy="989640"/>
+            <a:ext cx="8999280" cy="989280"/>
           </a:xfrm>
           <a:prstGeom prst="rect">
             <a:avLst/>
@@ -180,7 +180,7 @@
         <p:spPr>
           <a:xfrm>
             <a:off x="540000" y="2610000"/>
-            <a:ext cx="8999640" cy="2159640"/>
+            <a:ext cx="8999280" cy="2159280"/>
           </a:xfrm>
           <a:prstGeom prst="rect">
             <a:avLst/>
@@ -609,8 +609,8 @@
         </p:nvSpPr>
         <p:spPr>
           <a:xfrm>
-            <a:off x="180000" y="5308200"/>
-            <a:ext cx="2339640" cy="213840"/>
+            <a:off x="180000" y="5307840"/>
+            <a:ext cx="2339280" cy="213840"/>
           </a:xfrm>
           <a:prstGeom prst="rect">
             <a:avLst/>
@@ -687,8 +687,8 @@
         </p:nvSpPr>
         <p:spPr>
           <a:xfrm>
-            <a:off x="3420000" y="5308200"/>
-            <a:ext cx="3239640" cy="213840"/>
+            <a:off x="3420000" y="5307840"/>
+            <a:ext cx="3239280" cy="213840"/>
           </a:xfrm>
           <a:prstGeom prst="rect">
             <a:avLst/>
@@ -765,8 +765,8 @@
         </p:nvSpPr>
         <p:spPr>
           <a:xfrm>
-            <a:off x="7560000" y="5308200"/>
-            <a:ext cx="2339640" cy="213840"/>
+            <a:off x="7560000" y="5307840"/>
+            <a:ext cx="2339280" cy="213840"/>
           </a:xfrm>
           <a:prstGeom prst="rect">
             <a:avLst/>
@@ -809,7 +809,7 @@
                 <a:tab pos="0" algn="l"/>
               </a:tabLst>
             </a:pPr>
-            <a:fld id="{B446CF90-A3A9-48C1-BE21-ED946E0E8F39}" type="slidenum">
+            <a:fld id="{E8835A5C-6FAA-4474-9BEB-D5CFC2576F75}" type="slidenum">
               <a:rPr lang="en-US" sz="1400" b="0" u="none" strike="noStrike">
                 <a:solidFill>
                   <a:srgbClr val="FFFFFF"/>
@@ -840,7 +840,7 @@
         <p:spPr>
           <a:xfrm>
             <a:off x="1440000" y="1080000"/>
-            <a:ext cx="1439640" cy="1259640"/>
+            <a:ext cx="1439280" cy="1259280"/>
           </a:xfrm>
           <a:prstGeom prst="ellipse">
             <a:avLst/>
@@ -885,7 +885,7 @@
         <p:spPr>
           <a:xfrm>
             <a:off x="7380000" y="3960000"/>
-            <a:ext cx="1439640" cy="1259640"/>
+            <a:ext cx="1439280" cy="1259280"/>
           </a:xfrm>
           <a:prstGeom prst="ellipse">
             <a:avLst/>
@@ -930,7 +930,7 @@
         <p:spPr>
           <a:xfrm>
             <a:off x="9000000" y="2700000"/>
-            <a:ext cx="1259640" cy="1079640"/>
+            <a:ext cx="1259280" cy="1079280"/>
           </a:xfrm>
           <a:prstGeom prst="ellipse">
             <a:avLst/>
@@ -975,7 +975,7 @@
         <p:spPr>
           <a:xfrm>
             <a:off x="-180000" y="2430000"/>
-            <a:ext cx="1439640" cy="1349640"/>
+            <a:ext cx="1439280" cy="1349280"/>
           </a:xfrm>
           <a:prstGeom prst="ellipse">
             <a:avLst/>
@@ -1020,7 +1020,7 @@
         <p:spPr>
           <a:xfrm>
             <a:off x="540000" y="1080000"/>
-            <a:ext cx="719640" cy="719640"/>
+            <a:ext cx="719280" cy="719280"/>
           </a:xfrm>
           <a:prstGeom prst="ellipse">
             <a:avLst/>
@@ -1065,7 +1065,7 @@
         <p:spPr>
           <a:xfrm>
             <a:off x="0" y="1260000"/>
-            <a:ext cx="719640" cy="719640"/>
+            <a:ext cx="719280" cy="719280"/>
           </a:xfrm>
           <a:prstGeom prst="ellipse">
             <a:avLst/>
@@ -1110,7 +1110,7 @@
         <p:spPr>
           <a:xfrm>
             <a:off x="0" y="5220000"/>
-            <a:ext cx="1619640" cy="1259640"/>
+            <a:ext cx="1619280" cy="1259280"/>
           </a:xfrm>
           <a:prstGeom prst="ellipse">
             <a:avLst/>
@@ -1155,7 +1155,7 @@
         <p:spPr>
           <a:xfrm>
             <a:off x="9720000" y="4680000"/>
-            <a:ext cx="719640" cy="719640"/>
+            <a:ext cx="719280" cy="719280"/>
           </a:xfrm>
           <a:prstGeom prst="ellipse">
             <a:avLst/>
@@ -1200,7 +1200,7 @@
         <p:spPr>
           <a:xfrm>
             <a:off x="9540000" y="3420000"/>
-            <a:ext cx="719640" cy="719640"/>
+            <a:ext cx="719280" cy="719280"/>
           </a:xfrm>
           <a:prstGeom prst="ellipse">
             <a:avLst/>
@@ -1245,7 +1245,7 @@
         <p:spPr>
           <a:xfrm>
             <a:off x="8100000" y="4680000"/>
-            <a:ext cx="1079640" cy="842040"/>
+            <a:ext cx="1079280" cy="841680"/>
           </a:xfrm>
           <a:prstGeom prst="ellipse">
             <a:avLst/>
@@ -1290,7 +1290,7 @@
         <p:spPr>
           <a:xfrm>
             <a:off x="7920000" y="5400000"/>
-            <a:ext cx="899640" cy="899640"/>
+            <a:ext cx="899280" cy="899280"/>
           </a:xfrm>
           <a:prstGeom prst="ellipse">
             <a:avLst/>
@@ -1357,7 +1357,7 @@
         <p:spPr>
           <a:xfrm>
             <a:off x="0" y="0"/>
-            <a:ext cx="10079640" cy="5669640"/>
+            <a:ext cx="10079280" cy="5669280"/>
           </a:xfrm>
           <a:prstGeom prst="rect">
             <a:avLst/>
@@ -1412,7 +1412,7 @@
         <p:spPr>
           <a:xfrm>
             <a:off x="540000" y="1440000"/>
-            <a:ext cx="8999640" cy="989640"/>
+            <a:ext cx="8999280" cy="989280"/>
           </a:xfrm>
           <a:prstGeom prst="rect">
             <a:avLst/>
@@ -1490,7 +1490,7 @@
         <p:spPr>
           <a:xfrm>
             <a:off x="540000" y="2610000"/>
-            <a:ext cx="8999640" cy="2159640"/>
+            <a:ext cx="8999280" cy="2159280"/>
           </a:xfrm>
           <a:prstGeom prst="rect">
             <a:avLst/>
@@ -1919,8 +1919,8 @@
         </p:nvSpPr>
         <p:spPr>
           <a:xfrm>
-            <a:off x="180000" y="5308200"/>
-            <a:ext cx="2339640" cy="213840"/>
+            <a:off x="180000" y="5307840"/>
+            <a:ext cx="2339280" cy="213840"/>
           </a:xfrm>
           <a:prstGeom prst="rect">
             <a:avLst/>
@@ -1997,8 +1997,8 @@
         </p:nvSpPr>
         <p:spPr>
           <a:xfrm>
-            <a:off x="3420000" y="5308200"/>
-            <a:ext cx="3239640" cy="213840"/>
+            <a:off x="3420000" y="5307840"/>
+            <a:ext cx="3239280" cy="213840"/>
           </a:xfrm>
           <a:prstGeom prst="rect">
             <a:avLst/>
@@ -2075,8 +2075,8 @@
         </p:nvSpPr>
         <p:spPr>
           <a:xfrm>
-            <a:off x="7560000" y="5308200"/>
-            <a:ext cx="2339640" cy="213840"/>
+            <a:off x="7560000" y="5307840"/>
+            <a:ext cx="2339280" cy="213840"/>
           </a:xfrm>
           <a:prstGeom prst="rect">
             <a:avLst/>
@@ -2119,7 +2119,7 @@
                 <a:tab pos="0" algn="l"/>
               </a:tabLst>
             </a:pPr>
-            <a:fld id="{B6FB4801-1544-44A0-8B7B-DA34C747C62E}" type="slidenum">
+            <a:fld id="{CF0905A3-7842-42A1-B19C-751509D7128D}" type="slidenum">
               <a:rPr lang="en-US" sz="1400" b="0" u="none" strike="noStrike">
                 <a:solidFill>
                   <a:srgbClr val="FFFFFF"/>
@@ -2150,7 +2150,7 @@
         <p:spPr>
           <a:xfrm>
             <a:off x="1440000" y="1080000"/>
-            <a:ext cx="1439640" cy="1259640"/>
+            <a:ext cx="1439280" cy="1259280"/>
           </a:xfrm>
           <a:prstGeom prst="ellipse">
             <a:avLst/>
@@ -2195,7 +2195,7 @@
         <p:spPr>
           <a:xfrm>
             <a:off x="7380000" y="3960000"/>
-            <a:ext cx="1439640" cy="1259640"/>
+            <a:ext cx="1439280" cy="1259280"/>
           </a:xfrm>
           <a:prstGeom prst="ellipse">
             <a:avLst/>
@@ -2240,7 +2240,7 @@
         <p:spPr>
           <a:xfrm>
             <a:off x="9000000" y="2700000"/>
-            <a:ext cx="1259640" cy="1079640"/>
+            <a:ext cx="1259280" cy="1079280"/>
           </a:xfrm>
           <a:prstGeom prst="ellipse">
             <a:avLst/>
@@ -2285,7 +2285,7 @@
         <p:spPr>
           <a:xfrm>
             <a:off x="-180000" y="2430000"/>
-            <a:ext cx="1439640" cy="1349640"/>
+            <a:ext cx="1439280" cy="1349280"/>
           </a:xfrm>
           <a:prstGeom prst="ellipse">
             <a:avLst/>
@@ -2330,7 +2330,7 @@
         <p:spPr>
           <a:xfrm>
             <a:off x="540000" y="1080000"/>
-            <a:ext cx="719640" cy="719640"/>
+            <a:ext cx="719280" cy="719280"/>
           </a:xfrm>
           <a:prstGeom prst="ellipse">
             <a:avLst/>
@@ -2375,7 +2375,7 @@
         <p:spPr>
           <a:xfrm>
             <a:off x="0" y="1260000"/>
-            <a:ext cx="719640" cy="719640"/>
+            <a:ext cx="719280" cy="719280"/>
           </a:xfrm>
           <a:prstGeom prst="ellipse">
             <a:avLst/>
@@ -2420,7 +2420,7 @@
         <p:spPr>
           <a:xfrm>
             <a:off x="0" y="5220000"/>
-            <a:ext cx="1619640" cy="1259640"/>
+            <a:ext cx="1619280" cy="1259280"/>
           </a:xfrm>
           <a:prstGeom prst="ellipse">
             <a:avLst/>
@@ -2465,7 +2465,7 @@
         <p:spPr>
           <a:xfrm>
             <a:off x="9720000" y="4680000"/>
-            <a:ext cx="719640" cy="719640"/>
+            <a:ext cx="719280" cy="719280"/>
           </a:xfrm>
           <a:prstGeom prst="ellipse">
             <a:avLst/>
@@ -2510,7 +2510,7 @@
         <p:spPr>
           <a:xfrm>
             <a:off x="9540000" y="3420000"/>
-            <a:ext cx="719640" cy="719640"/>
+            <a:ext cx="719280" cy="719280"/>
           </a:xfrm>
           <a:prstGeom prst="ellipse">
             <a:avLst/>
@@ -2555,7 +2555,7 @@
         <p:spPr>
           <a:xfrm>
             <a:off x="8100000" y="4680000"/>
-            <a:ext cx="1079640" cy="842040"/>
+            <a:ext cx="1079280" cy="841680"/>
           </a:xfrm>
           <a:prstGeom prst="ellipse">
             <a:avLst/>
@@ -2600,7 +2600,7 @@
         <p:spPr>
           <a:xfrm>
             <a:off x="7920000" y="5400000"/>
-            <a:ext cx="899640" cy="899640"/>
+            <a:ext cx="899280" cy="899280"/>
           </a:xfrm>
           <a:prstGeom prst="ellipse">
             <a:avLst/>
@@ -2667,7 +2667,7 @@
         <p:spPr>
           <a:xfrm>
             <a:off x="0" y="0"/>
-            <a:ext cx="10079640" cy="5669640"/>
+            <a:ext cx="10079280" cy="5669280"/>
           </a:xfrm>
           <a:prstGeom prst="rect">
             <a:avLst/>
@@ -2718,7 +2718,7 @@
         <p:spPr>
           <a:xfrm flipH="1">
             <a:off x="-720" y="0"/>
-            <a:ext cx="10079640" cy="5669640"/>
+            <a:ext cx="10079280" cy="5669280"/>
           </a:xfrm>
           <a:prstGeom prst="rect">
             <a:avLst/>
@@ -2775,7 +2775,7 @@
         <p:spPr>
           <a:xfrm>
             <a:off x="1440000" y="1080000"/>
-            <a:ext cx="1439640" cy="1259640"/>
+            <a:ext cx="1439280" cy="1259280"/>
           </a:xfrm>
           <a:prstGeom prst="ellipse">
             <a:avLst/>
@@ -2820,7 +2820,7 @@
         <p:spPr>
           <a:xfrm>
             <a:off x="7380000" y="3960000"/>
-            <a:ext cx="1439640" cy="1259640"/>
+            <a:ext cx="1439280" cy="1259280"/>
           </a:xfrm>
           <a:prstGeom prst="ellipse">
             <a:avLst/>
@@ -2865,7 +2865,7 @@
         <p:spPr>
           <a:xfrm>
             <a:off x="9000000" y="2700000"/>
-            <a:ext cx="1259640" cy="1079640"/>
+            <a:ext cx="1259280" cy="1079280"/>
           </a:xfrm>
           <a:prstGeom prst="ellipse">
             <a:avLst/>
@@ -2910,7 +2910,7 @@
         <p:spPr>
           <a:xfrm>
             <a:off x="-180000" y="2430000"/>
-            <a:ext cx="1439640" cy="1349640"/>
+            <a:ext cx="1439280" cy="1349280"/>
           </a:xfrm>
           <a:prstGeom prst="ellipse">
             <a:avLst/>
@@ -2955,7 +2955,7 @@
         <p:spPr>
           <a:xfrm>
             <a:off x="540000" y="1080000"/>
-            <a:ext cx="719640" cy="719640"/>
+            <a:ext cx="719280" cy="719280"/>
           </a:xfrm>
           <a:prstGeom prst="ellipse">
             <a:avLst/>
@@ -3000,7 +3000,7 @@
         <p:spPr>
           <a:xfrm>
             <a:off x="0" y="1260000"/>
-            <a:ext cx="719640" cy="719640"/>
+            <a:ext cx="719280" cy="719280"/>
           </a:xfrm>
           <a:prstGeom prst="ellipse">
             <a:avLst/>
@@ -3045,7 +3045,7 @@
         <p:spPr>
           <a:xfrm>
             <a:off x="0" y="5220000"/>
-            <a:ext cx="1619640" cy="1259640"/>
+            <a:ext cx="1619280" cy="1259280"/>
           </a:xfrm>
           <a:prstGeom prst="ellipse">
             <a:avLst/>
@@ -3090,7 +3090,7 @@
         <p:spPr>
           <a:xfrm>
             <a:off x="9720000" y="4680000"/>
-            <a:ext cx="719640" cy="719640"/>
+            <a:ext cx="719280" cy="719280"/>
           </a:xfrm>
           <a:prstGeom prst="ellipse">
             <a:avLst/>
@@ -3135,7 +3135,7 @@
         <p:spPr>
           <a:xfrm>
             <a:off x="9540000" y="3420360"/>
-            <a:ext cx="719640" cy="719640"/>
+            <a:ext cx="719280" cy="719280"/>
           </a:xfrm>
           <a:prstGeom prst="ellipse">
             <a:avLst/>
@@ -3180,7 +3180,7 @@
         <p:spPr>
           <a:xfrm>
             <a:off x="8100000" y="4680000"/>
-            <a:ext cx="1079640" cy="842040"/>
+            <a:ext cx="1079280" cy="841680"/>
           </a:xfrm>
           <a:prstGeom prst="ellipse">
             <a:avLst/>
@@ -3225,7 +3225,7 @@
         <p:spPr>
           <a:xfrm>
             <a:off x="7920000" y="5400000"/>
-            <a:ext cx="899640" cy="899640"/>
+            <a:ext cx="899280" cy="899280"/>
           </a:xfrm>
           <a:prstGeom prst="ellipse">
             <a:avLst/>
@@ -3274,7 +3274,7 @@
         <p:spPr>
           <a:xfrm>
             <a:off x="540000" y="270000"/>
-            <a:ext cx="8999640" cy="989640"/>
+            <a:ext cx="8999280" cy="989280"/>
           </a:xfrm>
           <a:prstGeom prst="rect">
             <a:avLst/>
@@ -3352,7 +3352,7 @@
         <p:spPr>
           <a:xfrm>
             <a:off x="540000" y="1440000"/>
-            <a:ext cx="8999640" cy="3599640"/>
+            <a:ext cx="8999280" cy="3599280"/>
           </a:xfrm>
           <a:prstGeom prst="rect">
             <a:avLst/>
@@ -3785,8 +3785,8 @@
         </p:nvSpPr>
         <p:spPr>
           <a:xfrm>
-            <a:off x="180000" y="5308200"/>
-            <a:ext cx="2339640" cy="213840"/>
+            <a:off x="180000" y="5307840"/>
+            <a:ext cx="2339280" cy="213840"/>
           </a:xfrm>
           <a:prstGeom prst="rect">
             <a:avLst/>
@@ -3863,8 +3863,8 @@
         </p:nvSpPr>
         <p:spPr>
           <a:xfrm>
-            <a:off x="3420000" y="5308200"/>
-            <a:ext cx="3239640" cy="213840"/>
+            <a:off x="3420000" y="5307840"/>
+            <a:ext cx="3239280" cy="213840"/>
           </a:xfrm>
           <a:prstGeom prst="rect">
             <a:avLst/>
@@ -3941,8 +3941,8 @@
         </p:nvSpPr>
         <p:spPr>
           <a:xfrm>
-            <a:off x="7560000" y="5308200"/>
-            <a:ext cx="2339640" cy="213840"/>
+            <a:off x="7560000" y="5307840"/>
+            <a:ext cx="2339280" cy="213840"/>
           </a:xfrm>
           <a:prstGeom prst="rect">
             <a:avLst/>
@@ -3985,7 +3985,7 @@
                 <a:tab pos="0" algn="l"/>
               </a:tabLst>
             </a:pPr>
-            <a:fld id="{5A3985EA-14E8-4F4C-BE03-970DA8D8B579}" type="slidenum">
+            <a:fld id="{FD93241E-9781-45BE-9836-2CA3CD07BD76}" type="slidenum">
               <a:rPr lang="en-US" sz="1400" b="0" u="none" strike="noStrike">
                 <a:solidFill>
                   <a:srgbClr val="FFFFFF"/>
@@ -4038,7 +4038,7 @@
         <p:spPr>
           <a:xfrm>
             <a:off x="0" y="0"/>
-            <a:ext cx="10079640" cy="5669640"/>
+            <a:ext cx="10079280" cy="5669280"/>
           </a:xfrm>
           <a:prstGeom prst="rect">
             <a:avLst/>
@@ -4089,7 +4089,7 @@
         <p:spPr>
           <a:xfrm flipH="1">
             <a:off x="-720" y="0"/>
-            <a:ext cx="10079640" cy="5669640"/>
+            <a:ext cx="10079280" cy="5669280"/>
           </a:xfrm>
           <a:prstGeom prst="rect">
             <a:avLst/>
@@ -4146,7 +4146,7 @@
         <p:spPr>
           <a:xfrm>
             <a:off x="0" y="1260000"/>
-            <a:ext cx="10079640" cy="4409640"/>
+            <a:ext cx="10079280" cy="4409280"/>
           </a:xfrm>
           <a:prstGeom prst="rect">
             <a:avLst/>
@@ -4189,7 +4189,7 @@
         <p:spPr>
           <a:xfrm>
             <a:off x="1440000" y="1080000"/>
-            <a:ext cx="1439640" cy="1259640"/>
+            <a:ext cx="1439280" cy="1259280"/>
           </a:xfrm>
           <a:prstGeom prst="ellipse">
             <a:avLst/>
@@ -4234,7 +4234,7 @@
         <p:spPr>
           <a:xfrm>
             <a:off x="540000" y="1080000"/>
-            <a:ext cx="719640" cy="719640"/>
+            <a:ext cx="719280" cy="719280"/>
           </a:xfrm>
           <a:prstGeom prst="ellipse">
             <a:avLst/>
@@ -4283,7 +4283,7 @@
         <p:spPr>
           <a:xfrm>
             <a:off x="540000" y="270000"/>
-            <a:ext cx="8999640" cy="989640"/>
+            <a:ext cx="8999280" cy="989280"/>
           </a:xfrm>
           <a:prstGeom prst="rect">
             <a:avLst/>
@@ -4361,7 +4361,7 @@
         <p:spPr>
           <a:xfrm>
             <a:off x="540000" y="1440000"/>
-            <a:ext cx="8999640" cy="3599640"/>
+            <a:ext cx="8999280" cy="3599280"/>
           </a:xfrm>
           <a:prstGeom prst="rect">
             <a:avLst/>
@@ -4790,8 +4790,8 @@
         </p:nvSpPr>
         <p:spPr>
           <a:xfrm>
-            <a:off x="180000" y="5308200"/>
-            <a:ext cx="2339640" cy="213840"/>
+            <a:off x="180000" y="5307840"/>
+            <a:ext cx="2339280" cy="213840"/>
           </a:xfrm>
           <a:prstGeom prst="rect">
             <a:avLst/>
@@ -4868,8 +4868,8 @@
         </p:nvSpPr>
         <p:spPr>
           <a:xfrm>
-            <a:off x="3420000" y="5308200"/>
-            <a:ext cx="3239640" cy="213840"/>
+            <a:off x="3420000" y="5307840"/>
+            <a:ext cx="3239280" cy="213840"/>
           </a:xfrm>
           <a:prstGeom prst="rect">
             <a:avLst/>
@@ -4946,8 +4946,8 @@
         </p:nvSpPr>
         <p:spPr>
           <a:xfrm>
-            <a:off x="7560000" y="5308200"/>
-            <a:ext cx="2339640" cy="213840"/>
+            <a:off x="7560000" y="5307840"/>
+            <a:ext cx="2339280" cy="213840"/>
           </a:xfrm>
           <a:prstGeom prst="rect">
             <a:avLst/>
@@ -4990,7 +4990,7 @@
                 <a:tab pos="0" algn="l"/>
               </a:tabLst>
             </a:pPr>
-            <a:fld id="{847551EF-CD6A-40FB-BE97-F24033593F20}" type="slidenum">
+            <a:fld id="{5B5E5151-4D6B-4A80-9C3A-810520A04968}" type="slidenum">
               <a:rPr lang="en-US" sz="1400" b="0" u="none" strike="noStrike">
                 <a:solidFill>
                   <a:srgbClr val="000000"/>
@@ -5075,8 +5075,8 @@
         </p:nvSpPr>
         <p:spPr>
           <a:xfrm>
-            <a:off x="504000" y="1428480"/>
-            <a:ext cx="9071280" cy="947160"/>
+            <a:off x="504000" y="1428120"/>
+            <a:ext cx="9070920" cy="947520"/>
           </a:xfrm>
           <a:prstGeom prst="rect">
             <a:avLst/>
@@ -5134,8 +5134,8 @@
         </p:nvSpPr>
         <p:spPr>
           <a:xfrm>
-            <a:off x="504000" y="2591640"/>
-            <a:ext cx="9071280" cy="2023200"/>
+            <a:off x="504000" y="2591280"/>
+            <a:ext cx="9070920" cy="2023560"/>
           </a:xfrm>
           <a:prstGeom prst="rect">
             <a:avLst/>
@@ -5259,8 +5259,8 @@
         </p:nvSpPr>
         <p:spPr>
           <a:xfrm>
-            <a:off x="540000" y="269640"/>
-            <a:ext cx="8999640" cy="990360"/>
+            <a:off x="540000" y="269280"/>
+            <a:ext cx="8999280" cy="990720"/>
           </a:xfrm>
           <a:prstGeom prst="rect">
             <a:avLst/>
@@ -5319,7 +5319,7 @@
         <p:spPr>
           <a:xfrm>
             <a:off x="540000" y="1440000"/>
-            <a:ext cx="8999640" cy="3599640"/>
+            <a:ext cx="8999280" cy="3599280"/>
           </a:xfrm>
           <a:prstGeom prst="rect">
             <a:avLst/>
@@ -5563,7 +5563,7 @@
         <p:txBody>
           <a:bodyPr/>
           <a:p>
-            <a:fld id="{14D2319C-B1E9-42C6-8B6A-855944335088}" type="slidenum">
+            <a:fld id="{77DDD242-507C-4767-874A-2F31D73D3B5B}" type="slidenum">
               <a:t>10</a:t>
             </a:fld>
           </a:p>
@@ -5582,32 +5582,32 @@
   <p:timing>
     <p:tnLst>
       <p:par>
-        <p:cTn id="264" dur="indefinite" restart="never" nodeType="tmRoot">
+        <p:cTn id="244" dur="indefinite" restart="never" nodeType="tmRoot">
           <p:childTnLst>
             <p:seq>
-              <p:cTn id="265" dur="indefinite" nodeType="mainSeq">
+              <p:cTn id="245" dur="indefinite" nodeType="mainSeq">
                 <p:childTnLst>
                   <p:par>
-                    <p:cTn id="266" fill="hold">
+                    <p:cTn id="246" fill="hold">
                       <p:stCondLst>
                         <p:cond delay="indefinite"/>
                       </p:stCondLst>
                       <p:childTnLst>
                         <p:par>
-                          <p:cTn id="267" fill="hold">
+                          <p:cTn id="247" fill="hold">
                             <p:stCondLst>
                               <p:cond delay="0"/>
                             </p:stCondLst>
                             <p:childTnLst>
                               <p:par>
-                                <p:cTn id="268" presetID="1" presetClass="entr" fill="hold" nodeType="clickEffect">
+                                <p:cTn id="248" presetID="1" presetClass="entr" fill="hold" nodeType="clickEffect">
                                   <p:stCondLst>
                                     <p:cond delay="0"/>
                                   </p:stCondLst>
                                   <p:childTnLst>
                                     <p:set>
                                       <p:cBhvr>
-                                        <p:cTn id="269" dur="1" fill="hold">
+                                        <p:cTn id="249" dur="1" fill="hold">
                                           <p:stCondLst>
                                             <p:cond delay="0"/>
                                           </p:stCondLst>
@@ -5637,26 +5637,26 @@
                     </p:cTn>
                   </p:par>
                   <p:par>
-                    <p:cTn id="270" fill="hold">
+                    <p:cTn id="250" fill="hold">
                       <p:stCondLst>
                         <p:cond delay="indefinite"/>
                       </p:stCondLst>
                       <p:childTnLst>
                         <p:par>
-                          <p:cTn id="271" fill="hold">
+                          <p:cTn id="251" fill="hold">
                             <p:stCondLst>
                               <p:cond delay="0"/>
                             </p:stCondLst>
                             <p:childTnLst>
                               <p:par>
-                                <p:cTn id="272" presetID="1" presetClass="entr" fill="hold" nodeType="clickEffect">
+                                <p:cTn id="252" presetID="1" presetClass="entr" fill="hold" nodeType="clickEffect">
                                   <p:stCondLst>
                                     <p:cond delay="0"/>
                                   </p:stCondLst>
                                   <p:childTnLst>
                                     <p:set>
                                       <p:cBhvr>
-                                        <p:cTn id="273" dur="1" fill="hold">
+                                        <p:cTn id="253" dur="1" fill="hold">
                                           <p:stCondLst>
                                             <p:cond delay="0"/>
                                           </p:stCondLst>
@@ -5686,26 +5686,26 @@
                     </p:cTn>
                   </p:par>
                   <p:par>
-                    <p:cTn id="274" fill="hold">
+                    <p:cTn id="254" fill="hold">
                       <p:stCondLst>
                         <p:cond delay="indefinite"/>
                       </p:stCondLst>
                       <p:childTnLst>
                         <p:par>
-                          <p:cTn id="275" fill="hold">
+                          <p:cTn id="255" fill="hold">
                             <p:stCondLst>
                               <p:cond delay="0"/>
                             </p:stCondLst>
                             <p:childTnLst>
                               <p:par>
-                                <p:cTn id="276" presetID="1" presetClass="entr" fill="hold" nodeType="clickEffect">
+                                <p:cTn id="256" presetID="1" presetClass="entr" fill="hold" nodeType="clickEffect">
                                   <p:stCondLst>
                                     <p:cond delay="0"/>
                                   </p:stCondLst>
                                   <p:childTnLst>
                                     <p:set>
                                       <p:cBhvr>
-                                        <p:cTn id="277" dur="1" fill="hold">
+                                        <p:cTn id="257" dur="1" fill="hold">
                                           <p:stCondLst>
                                             <p:cond delay="0"/>
                                           </p:stCondLst>
@@ -5735,26 +5735,26 @@
                     </p:cTn>
                   </p:par>
                   <p:par>
-                    <p:cTn id="278" fill="hold">
+                    <p:cTn id="258" fill="hold">
                       <p:stCondLst>
                         <p:cond delay="indefinite"/>
                       </p:stCondLst>
                       <p:childTnLst>
                         <p:par>
-                          <p:cTn id="279" fill="hold">
+                          <p:cTn id="259" fill="hold">
                             <p:stCondLst>
                               <p:cond delay="0"/>
                             </p:stCondLst>
                             <p:childTnLst>
                               <p:par>
-                                <p:cTn id="280" presetID="1" presetClass="entr" fill="hold" nodeType="clickEffect">
+                                <p:cTn id="260" presetID="1" presetClass="entr" fill="hold" nodeType="clickEffect">
                                   <p:stCondLst>
                                     <p:cond delay="0"/>
                                   </p:stCondLst>
                                   <p:childTnLst>
                                     <p:set>
                                       <p:cBhvr>
-                                        <p:cTn id="281" dur="1" fill="hold">
+                                        <p:cTn id="261" dur="1" fill="hold">
                                           <p:stCondLst>
                                             <p:cond delay="0"/>
                                           </p:stCondLst>
@@ -5784,26 +5784,26 @@
                     </p:cTn>
                   </p:par>
                   <p:par>
-                    <p:cTn id="282" fill="hold">
+                    <p:cTn id="262" fill="hold">
                       <p:stCondLst>
                         <p:cond delay="indefinite"/>
                       </p:stCondLst>
                       <p:childTnLst>
                         <p:par>
-                          <p:cTn id="283" fill="hold">
+                          <p:cTn id="263" fill="hold">
                             <p:stCondLst>
                               <p:cond delay="0"/>
                             </p:stCondLst>
                             <p:childTnLst>
                               <p:par>
-                                <p:cTn id="284" presetID="1" presetClass="entr" fill="hold" nodeType="clickEffect">
+                                <p:cTn id="264" presetID="1" presetClass="entr" fill="hold" nodeType="clickEffect">
                                   <p:stCondLst>
                                     <p:cond delay="0"/>
                                   </p:stCondLst>
                                   <p:childTnLst>
                                     <p:set>
                                       <p:cBhvr>
-                                        <p:cTn id="285" dur="1" fill="hold">
+                                        <p:cTn id="265" dur="1" fill="hold">
                                           <p:stCondLst>
                                             <p:cond delay="0"/>
                                           </p:stCondLst>
@@ -5833,26 +5833,26 @@
                     </p:cTn>
                   </p:par>
                   <p:par>
-                    <p:cTn id="286" fill="hold">
+                    <p:cTn id="266" fill="hold">
                       <p:stCondLst>
                         <p:cond delay="indefinite"/>
                       </p:stCondLst>
                       <p:childTnLst>
                         <p:par>
-                          <p:cTn id="287" fill="hold">
+                          <p:cTn id="267" fill="hold">
                             <p:stCondLst>
                               <p:cond delay="0"/>
                             </p:stCondLst>
                             <p:childTnLst>
                               <p:par>
-                                <p:cTn id="288" presetID="1" presetClass="entr" fill="hold" nodeType="clickEffect">
+                                <p:cTn id="268" presetID="1" presetClass="entr" fill="hold" nodeType="clickEffect">
                                   <p:stCondLst>
                                     <p:cond delay="0"/>
                                   </p:stCondLst>
                                   <p:childTnLst>
                                     <p:set>
                                       <p:cBhvr>
-                                        <p:cTn id="289" dur="1" fill="hold">
+                                        <p:cTn id="269" dur="1" fill="hold">
                                           <p:stCondLst>
                                             <p:cond delay="0"/>
                                           </p:stCondLst>
@@ -5936,7 +5936,7 @@
         <p:spPr>
           <a:xfrm>
             <a:off x="540000" y="1440000"/>
-            <a:ext cx="8999640" cy="3599640"/>
+            <a:ext cx="8999280" cy="3599280"/>
           </a:xfrm>
           <a:prstGeom prst="rect">
             <a:avLst/>
@@ -6003,8 +6003,8 @@
         </p:nvSpPr>
         <p:spPr>
           <a:xfrm>
-            <a:off x="540000" y="269640"/>
-            <a:ext cx="8999640" cy="990360"/>
+            <a:off x="540000" y="269280"/>
+            <a:ext cx="8999280" cy="990720"/>
           </a:xfrm>
           <a:prstGeom prst="rect">
             <a:avLst/>
@@ -6065,7 +6065,7 @@
         <p:spPr>
           <a:xfrm>
             <a:off x="540000" y="2057400"/>
-            <a:ext cx="4571640" cy="3050280"/>
+            <a:ext cx="4571280" cy="3049920"/>
           </a:xfrm>
           <a:prstGeom prst="rect">
             <a:avLst/>
@@ -6091,7 +6091,7 @@
         <p:spPr>
           <a:xfrm>
             <a:off x="6851880" y="136440"/>
-            <a:ext cx="2977560" cy="2149200"/>
+            <a:ext cx="2977200" cy="2148840"/>
           </a:xfrm>
           <a:prstGeom prst="rect">
             <a:avLst/>
@@ -6116,7 +6116,7 @@
         <p:txBody>
           <a:bodyPr/>
           <a:p>
-            <a:fld id="{F70E88E2-DDE3-47C8-B567-853A8B8BA9D6}" type="slidenum">
+            <a:fld id="{8F20EC60-F30B-4758-8C10-90BBD0C1F1D9}" type="slidenum">
               <a:t>2</a:t>
             </a:fld>
           </a:p>
@@ -6153,7 +6153,7 @@
                             </p:stCondLst>
                             <p:childTnLst>
                               <p:par>
-                                <p:cTn id="5" presetClass="entr" fill="hold" nodeType="clickEffect" presetSubtype="16">
+                                <p:cTn id="5" presetClass="entr" fill="hold" nodeType="clickEffect">
                                   <p:stCondLst>
                                     <p:cond delay="0"/>
                                   </p:stCondLst>
@@ -6300,8 +6300,8 @@
         </p:nvSpPr>
         <p:spPr>
           <a:xfrm>
-            <a:off x="540000" y="269640"/>
-            <a:ext cx="8999640" cy="990360"/>
+            <a:off x="540000" y="269280"/>
+            <a:ext cx="8999280" cy="990720"/>
           </a:xfrm>
           <a:prstGeom prst="rect">
             <a:avLst/>
@@ -6360,7 +6360,7 @@
         <p:spPr>
           <a:xfrm>
             <a:off x="540000" y="1440000"/>
-            <a:ext cx="8999640" cy="3599640"/>
+            <a:ext cx="8999280" cy="3599280"/>
           </a:xfrm>
           <a:prstGeom prst="rect">
             <a:avLst/>
@@ -6674,7 +6674,7 @@
         <p:txBody>
           <a:bodyPr/>
           <a:p>
-            <a:fld id="{D0EC7E5D-672A-43DF-8601-1DA75626379F}" type="slidenum">
+            <a:fld id="{EE59E5B6-BAD8-43ED-A23B-74BD602D00FC}" type="slidenum">
               <a:t>3</a:t>
             </a:fld>
           </a:p>
@@ -7228,8 +7228,8 @@
         </p:nvSpPr>
         <p:spPr>
           <a:xfrm>
-            <a:off x="540000" y="269640"/>
-            <a:ext cx="8999640" cy="990360"/>
+            <a:off x="540000" y="269280"/>
+            <a:ext cx="8999280" cy="990720"/>
           </a:xfrm>
           <a:prstGeom prst="rect">
             <a:avLst/>
@@ -7288,7 +7288,7 @@
         <p:spPr>
           <a:xfrm>
             <a:off x="540000" y="1440000"/>
-            <a:ext cx="8999640" cy="3599640"/>
+            <a:ext cx="8999280" cy="3599280"/>
           </a:xfrm>
           <a:prstGeom prst="rect">
             <a:avLst/>
@@ -7665,28 +7665,6 @@
               <a:latin typeface="Arial"/>
             </a:endParaRPr>
           </a:p>
-          <a:p>
-            <a:pPr indent="0" algn="l">
-              <a:lnSpc>
-                <a:spcPct val="100000"/>
-              </a:lnSpc>
-              <a:spcAft>
-                <a:spcPts val="1057"/>
-              </a:spcAft>
-              <a:buNone/>
-              <a:tabLst>
-                <a:tab pos="0" algn="l"/>
-              </a:tabLst>
-            </a:pPr>
-            <a:endParaRPr lang="en-US" sz="2400" b="0" u="none" strike="noStrike">
-              <a:solidFill>
-                <a:srgbClr val="000000"/>
-              </a:solidFill>
-              <a:effectLst/>
-              <a:uFillTx/>
-              <a:latin typeface="Arial"/>
-            </a:endParaRPr>
-          </a:p>
         </p:txBody>
       </p:sp>
       <p:sp>
@@ -7703,7 +7681,7 @@
         <p:txBody>
           <a:bodyPr/>
           <a:p>
-            <a:fld id="{515D7F1F-F1AB-4326-97A9-73D82D80767F}" type="slidenum">
+            <a:fld id="{AFF8E515-9FA6-4DD6-A8CD-4E0DC4C6D33A}" type="slidenum">
               <a:t>4</a:t>
             </a:fld>
           </a:p>
@@ -8222,8 +8200,8 @@
         </p:nvSpPr>
         <p:spPr>
           <a:xfrm>
-            <a:off x="540000" y="269640"/>
-            <a:ext cx="8999640" cy="990360"/>
+            <a:off x="540000" y="269280"/>
+            <a:ext cx="8999280" cy="990720"/>
           </a:xfrm>
           <a:prstGeom prst="rect">
             <a:avLst/>
@@ -8282,7 +8260,7 @@
         <p:spPr>
           <a:xfrm>
             <a:off x="540000" y="1440000"/>
-            <a:ext cx="8999640" cy="3599640"/>
+            <a:ext cx="8999280" cy="3599280"/>
           </a:xfrm>
           <a:prstGeom prst="rect">
             <a:avLst/>
@@ -8298,7 +8276,7 @@
         </p:spPr>
         <p:txBody>
           <a:bodyPr lIns="0" tIns="0" rIns="0" bIns="0" anchor="t">
-            <a:normAutofit fontScale="85000" lnSpcReduction="9999"/>
+            <a:normAutofit fontScale="85000" lnSpcReduction="19999"/>
           </a:bodyPr>
           <a:p>
             <a:pPr marL="432000" indent="-324000" algn="l">
@@ -8441,6 +8419,41 @@
             </a:endParaRPr>
           </a:p>
           <a:p>
+            <a:pPr marL="1296000" lvl="2" indent="-288000" algn="l">
+              <a:lnSpc>
+                <a:spcPct val="100000"/>
+              </a:lnSpc>
+              <a:spcAft>
+                <a:spcPts val="632"/>
+              </a:spcAft>
+              <a:buClr>
+                <a:srgbClr val="000000"/>
+              </a:buClr>
+              <a:buSzPct val="45000"/>
+              <a:buFont typeface="Wingdings" charset="2"/>
+              <a:buChar char=""/>
+            </a:pPr>
+            <a:r>
+              <a:rPr lang="en-US" sz="1800" b="0" u="none" strike="noStrike">
+                <a:solidFill>
+                  <a:srgbClr val="000000"/>
+                </a:solidFill>
+                <a:effectLst/>
+                <a:uFillTx/>
+                <a:latin typeface="Arial"/>
+              </a:rPr>
+              <a:t>Core functionality</a:t>
+            </a:r>
+            <a:endParaRPr lang="en-US" sz="1800" b="0" u="none" strike="noStrike">
+              <a:solidFill>
+                <a:srgbClr val="000000"/>
+              </a:solidFill>
+              <a:effectLst/>
+              <a:uFillTx/>
+              <a:latin typeface="Arial"/>
+            </a:endParaRPr>
+          </a:p>
+          <a:p>
             <a:pPr marL="432000" indent="-324000" algn="l">
               <a:lnSpc>
                 <a:spcPct val="100000"/>
@@ -8639,66 +8652,9 @@
                 <a:uFillTx/>
                 <a:latin typeface="Arial"/>
               </a:rPr>
-              <a:t>Object with category, places, warrantly, insurance.</a:t>
+              <a:t>Object with category, places</a:t>
             </a:r>
             <a:endParaRPr lang="en-US" sz="1800" b="0" u="none" strike="noStrike">
-              <a:solidFill>
-                <a:srgbClr val="000000"/>
-              </a:solidFill>
-              <a:effectLst/>
-              <a:uFillTx/>
-              <a:latin typeface="Arial"/>
-            </a:endParaRPr>
-          </a:p>
-          <a:p>
-            <a:pPr marL="1296000" lvl="2" indent="-288000" algn="l">
-              <a:lnSpc>
-                <a:spcPct val="100000"/>
-              </a:lnSpc>
-              <a:spcAft>
-                <a:spcPts val="632"/>
-              </a:spcAft>
-              <a:buClr>
-                <a:srgbClr val="000000"/>
-              </a:buClr>
-              <a:buSzPct val="45000"/>
-              <a:buFont typeface="Wingdings" charset="2"/>
-              <a:buChar char=""/>
-            </a:pPr>
-            <a:r>
-              <a:rPr lang="en-US" sz="1800" b="0" u="none" strike="noStrike">
-                <a:solidFill>
-                  <a:srgbClr val="000000"/>
-                </a:solidFill>
-                <a:effectLst/>
-                <a:uFillTx/>
-                <a:latin typeface="Arial"/>
-              </a:rPr>
-              <a:t>Save and load via local file</a:t>
-            </a:r>
-            <a:endParaRPr lang="en-US" sz="1800" b="0" u="none" strike="noStrike">
-              <a:solidFill>
-                <a:srgbClr val="000000"/>
-              </a:solidFill>
-              <a:effectLst/>
-              <a:uFillTx/>
-              <a:latin typeface="Arial"/>
-            </a:endParaRPr>
-          </a:p>
-          <a:p>
-            <a:pPr marL="432000" indent="0" algn="l">
-              <a:lnSpc>
-                <a:spcPct val="100000"/>
-              </a:lnSpc>
-              <a:spcAft>
-                <a:spcPts val="1057"/>
-              </a:spcAft>
-              <a:buNone/>
-              <a:tabLst>
-                <a:tab pos="0" algn="l"/>
-              </a:tabLst>
-            </a:pPr>
-            <a:endParaRPr lang="en-US" sz="2400" b="0" u="none" strike="noStrike">
               <a:solidFill>
                 <a:srgbClr val="000000"/>
               </a:solidFill>
@@ -8724,7 +8680,7 @@
         <p:spPr>
           <a:xfrm>
             <a:off x="0" y="0"/>
-            <a:ext cx="10114920" cy="5669640"/>
+            <a:ext cx="10114560" cy="5669280"/>
           </a:xfrm>
           <a:prstGeom prst="rect">
             <a:avLst/>
@@ -8749,7 +8705,7 @@
         <p:txBody>
           <a:bodyPr/>
           <a:p>
-            <a:fld id="{DF663548-ADB1-4CA0-8C09-3A63F719112A}" type="slidenum">
+            <a:fld id="{B2F91EB2-E451-4C97-BF61-1DC734132AB8}" type="slidenum">
               <a:t>5</a:t>
             </a:fld>
           </a:p>
@@ -9436,8 +9392,8 @@
         </p:nvSpPr>
         <p:spPr>
           <a:xfrm>
-            <a:off x="540000" y="269640"/>
-            <a:ext cx="8999640" cy="990360"/>
+            <a:off x="540000" y="269280"/>
+            <a:ext cx="8999280" cy="990720"/>
           </a:xfrm>
           <a:prstGeom prst="rect">
             <a:avLst/>
@@ -9496,7 +9452,7 @@
         <p:spPr>
           <a:xfrm>
             <a:off x="540000" y="1440000"/>
-            <a:ext cx="8999640" cy="3599640"/>
+            <a:ext cx="8999280" cy="3599280"/>
           </a:xfrm>
           <a:prstGeom prst="rect">
             <a:avLst/>
@@ -9950,7 +9906,7 @@
         <p:txBody>
           <a:bodyPr/>
           <a:p>
-            <a:fld id="{39F0A67B-A9F4-4C83-A0DF-6B63CFB71D08}" type="slidenum">
+            <a:fld id="{E5236432-1A17-45D2-ADDC-D5AD4D2D133B}" type="slidenum">
               <a:t>6</a:t>
             </a:fld>
           </a:p>
@@ -10616,8 +10572,8 @@
         </p:nvSpPr>
         <p:spPr>
           <a:xfrm>
-            <a:off x="540000" y="269640"/>
-            <a:ext cx="8999640" cy="990360"/>
+            <a:off x="540000" y="269280"/>
+            <a:ext cx="8999280" cy="990720"/>
           </a:xfrm>
           <a:prstGeom prst="rect">
             <a:avLst/>
@@ -10676,7 +10632,7 @@
         <p:spPr>
           <a:xfrm>
             <a:off x="540000" y="1440000"/>
-            <a:ext cx="8999640" cy="3599640"/>
+            <a:ext cx="8999280" cy="3599280"/>
           </a:xfrm>
           <a:prstGeom prst="rect">
             <a:avLst/>
@@ -10753,41 +10709,6 @@
                 <a:uFillTx/>
                 <a:latin typeface="Arial"/>
               </a:rPr>
-              <a:t>Copy the data to json file</a:t>
-            </a:r>
-            <a:endParaRPr lang="en-US" sz="2400" b="0" u="none" strike="noStrike">
-              <a:solidFill>
-                <a:srgbClr val="000000"/>
-              </a:solidFill>
-              <a:effectLst/>
-              <a:uFillTx/>
-              <a:latin typeface="Arial"/>
-            </a:endParaRPr>
-          </a:p>
-          <a:p>
-            <a:pPr marL="432000" indent="-324000" algn="l">
-              <a:lnSpc>
-                <a:spcPct val="100000"/>
-              </a:lnSpc>
-              <a:spcAft>
-                <a:spcPts val="1057"/>
-              </a:spcAft>
-              <a:buClr>
-                <a:srgbClr val="000000"/>
-              </a:buClr>
-              <a:buSzPct val="45000"/>
-              <a:buFont typeface="Wingdings" charset="2"/>
-              <a:buChar char=""/>
-            </a:pPr>
-            <a:r>
-              <a:rPr lang="en-US" sz="2400" b="0" u="none" strike="noStrike">
-                <a:solidFill>
-                  <a:srgbClr val="000000"/>
-                </a:solidFill>
-                <a:effectLst/>
-                <a:uFillTx/>
-                <a:latin typeface="Arial"/>
-              </a:rPr>
               <a:t>Enter and exit full screen</a:t>
             </a:r>
             <a:endParaRPr lang="en-US" sz="2400" b="0" u="none" strike="noStrike">
@@ -10815,7 +10736,7 @@
         <p:txBody>
           <a:bodyPr/>
           <a:p>
-            <a:fld id="{08F279C4-D874-495B-B1B5-AEF7DF6DD67E}" type="slidenum">
+            <a:fld id="{CCBC1469-477C-40AC-AEE2-7527095D4B9E}" type="slidenum">
               <a:t>7</a:t>
             </a:fld>
           </a:p>
@@ -10937,55 +10858,6 @@
                       </p:childTnLst>
                     </p:cTn>
                   </p:par>
-                  <p:par>
-                    <p:cTn id="200" fill="hold">
-                      <p:stCondLst>
-                        <p:cond delay="indefinite"/>
-                      </p:stCondLst>
-                      <p:childTnLst>
-                        <p:par>
-                          <p:cTn id="201" fill="hold">
-                            <p:stCondLst>
-                              <p:cond delay="0"/>
-                            </p:stCondLst>
-                            <p:childTnLst>
-                              <p:par>
-                                <p:cTn id="202" presetID="1" presetClass="entr" fill="hold" nodeType="clickEffect">
-                                  <p:stCondLst>
-                                    <p:cond delay="0"/>
-                                  </p:stCondLst>
-                                  <p:childTnLst>
-                                    <p:set>
-                                      <p:cBhvr>
-                                        <p:cTn id="203" dur="1" fill="hold">
-                                          <p:stCondLst>
-                                            <p:cond delay="0"/>
-                                          </p:stCondLst>
-                                        </p:cTn>
-                                        <p:tgtEl>
-                                          <p:spTgt spid="80">
-                                            <p:txEl>
-                                              <p:pRg st="2" end="2"/>
-                                            </p:txEl>
-                                          </p:spTgt>
-                                        </p:tgtEl>
-                                        <p:attrNameLst>
-                                          <p:attrName>style.visibility</p:attrName>
-                                        </p:attrNameLst>
-                                      </p:cBhvr>
-                                      <p:to>
-                                        <p:strVal val="visible"/>
-                                      </p:to>
-                                    </p:set>
-                                  </p:childTnLst>
-                                </p:cTn>
-                              </p:par>
-                            </p:childTnLst>
-                          </p:cTn>
-                        </p:par>
-                      </p:childTnLst>
-                    </p:cTn>
-                  </p:par>
                 </p:childTnLst>
               </p:cTn>
               <p:prevCondLst>
@@ -11040,8 +10912,8 @@
         </p:nvSpPr>
         <p:spPr>
           <a:xfrm>
-            <a:off x="540000" y="269640"/>
-            <a:ext cx="8999640" cy="990360"/>
+            <a:off x="540000" y="269280"/>
+            <a:ext cx="8999280" cy="990720"/>
           </a:xfrm>
           <a:prstGeom prst="rect">
             <a:avLst/>
@@ -11100,7 +10972,7 @@
         <p:spPr>
           <a:xfrm>
             <a:off x="540000" y="1440000"/>
-            <a:ext cx="8999640" cy="3599640"/>
+            <a:ext cx="8999280" cy="3599280"/>
           </a:xfrm>
           <a:prstGeom prst="rect">
             <a:avLst/>
@@ -11177,7 +11049,7 @@
                 <a:uFillTx/>
                 <a:latin typeface="Arial"/>
               </a:rPr>
-              <a:t>ETO.Forms</a:t>
+              <a:t>Windows, MacOS, Linux</a:t>
             </a:r>
             <a:endParaRPr lang="en-US" sz="2400" b="0" u="none" strike="noStrike">
               <a:solidFill>
@@ -11212,7 +11084,7 @@
                 <a:uFillTx/>
                 <a:latin typeface="Arial"/>
               </a:rPr>
-              <a:t>FlashCap</a:t>
+              <a:t>ETO.Forms</a:t>
             </a:r>
             <a:endParaRPr lang="en-US" sz="2400" b="0" u="none" strike="noStrike">
               <a:solidFill>
@@ -11247,7 +11119,7 @@
                 <a:uFillTx/>
                 <a:latin typeface="Arial"/>
               </a:rPr>
-              <a:t>Xzing.Net</a:t>
+              <a:t>FlashCap</a:t>
             </a:r>
             <a:endParaRPr lang="en-US" sz="2400" b="0" u="none" strike="noStrike">
               <a:solidFill>
@@ -11282,7 +11154,7 @@
                 <a:uFillTx/>
                 <a:latin typeface="Arial"/>
               </a:rPr>
-              <a:t>CSVHelpers</a:t>
+              <a:t>Xzing.Net</a:t>
             </a:r>
             <a:endParaRPr lang="en-US" sz="2400" b="0" u="none" strike="noStrike">
               <a:solidFill>
@@ -11317,7 +11189,7 @@
                 <a:uFillTx/>
                 <a:latin typeface="Arial"/>
               </a:rPr>
-              <a:t>Windows, MacOS, Linux</a:t>
+              <a:t>CSVHelpers</a:t>
             </a:r>
             <a:endParaRPr lang="en-US" sz="2400" b="0" u="none" strike="noStrike">
               <a:solidFill>
@@ -11344,7 +11216,7 @@
         <p:txBody>
           <a:bodyPr/>
           <a:p>
-            <a:fld id="{5188D310-0F19-441C-A176-78B4F049AE61}" type="slidenum">
+            <a:fld id="{7DD06659-4010-402D-BB5F-687EEE1AA88F}" type="slidenum">
               <a:t>8</a:t>
             </a:fld>
           </a:p>
@@ -11363,32 +11235,32 @@
   <p:timing>
     <p:tnLst>
       <p:par>
-        <p:cTn id="204" dur="indefinite" restart="never" nodeType="tmRoot">
+        <p:cTn id="200" dur="indefinite" restart="never" nodeType="tmRoot">
           <p:childTnLst>
             <p:seq>
-              <p:cTn id="205" dur="indefinite" nodeType="mainSeq">
+              <p:cTn id="201" dur="indefinite" nodeType="mainSeq">
                 <p:childTnLst>
                   <p:par>
-                    <p:cTn id="206" fill="hold">
+                    <p:cTn id="202" fill="hold">
                       <p:stCondLst>
                         <p:cond delay="indefinite"/>
                       </p:stCondLst>
                       <p:childTnLst>
                         <p:par>
-                          <p:cTn id="207" fill="hold">
+                          <p:cTn id="203" fill="hold">
                             <p:stCondLst>
                               <p:cond delay="0"/>
                             </p:stCondLst>
                             <p:childTnLst>
                               <p:par>
-                                <p:cTn id="208" presetID="1" presetClass="entr" fill="hold" nodeType="clickEffect">
+                                <p:cTn id="204" presetID="1" presetClass="entr" fill="hold" nodeType="clickEffect">
                                   <p:stCondLst>
                                     <p:cond delay="0"/>
                                   </p:stCondLst>
                                   <p:childTnLst>
                                     <p:set>
                                       <p:cBhvr>
-                                        <p:cTn id="209" dur="1" fill="hold">
+                                        <p:cTn id="205" dur="1" fill="hold">
                                           <p:stCondLst>
                                             <p:cond delay="0"/>
                                           </p:stCondLst>
@@ -11418,26 +11290,26 @@
                     </p:cTn>
                   </p:par>
                   <p:par>
-                    <p:cTn id="210" fill="hold">
+                    <p:cTn id="206" fill="hold">
                       <p:stCondLst>
                         <p:cond delay="indefinite"/>
                       </p:stCondLst>
                       <p:childTnLst>
                         <p:par>
-                          <p:cTn id="211" fill="hold">
+                          <p:cTn id="207" fill="hold">
                             <p:stCondLst>
                               <p:cond delay="0"/>
                             </p:stCondLst>
                             <p:childTnLst>
                               <p:par>
-                                <p:cTn id="212" presetID="1" presetClass="entr" fill="hold" nodeType="clickEffect">
+                                <p:cTn id="208" presetID="1" presetClass="entr" fill="hold" nodeType="clickEffect">
                                   <p:stCondLst>
                                     <p:cond delay="0"/>
                                   </p:stCondLst>
                                   <p:childTnLst>
                                     <p:set>
                                       <p:cBhvr>
-                                        <p:cTn id="213" dur="1" fill="hold">
+                                        <p:cTn id="209" dur="1" fill="hold">
                                           <p:stCondLst>
                                             <p:cond delay="0"/>
                                           </p:stCondLst>
@@ -11446,202 +11318,6 @@
                                           <p:spTgt spid="82">
                                             <p:txEl>
                                               <p:pRg st="1" end="1"/>
-                                            </p:txEl>
-                                          </p:spTgt>
-                                        </p:tgtEl>
-                                        <p:attrNameLst>
-                                          <p:attrName>style.visibility</p:attrName>
-                                        </p:attrNameLst>
-                                      </p:cBhvr>
-                                      <p:to>
-                                        <p:strVal val="visible"/>
-                                      </p:to>
-                                    </p:set>
-                                  </p:childTnLst>
-                                </p:cTn>
-                              </p:par>
-                            </p:childTnLst>
-                          </p:cTn>
-                        </p:par>
-                      </p:childTnLst>
-                    </p:cTn>
-                  </p:par>
-                  <p:par>
-                    <p:cTn id="214" fill="hold">
-                      <p:stCondLst>
-                        <p:cond delay="indefinite"/>
-                      </p:stCondLst>
-                      <p:childTnLst>
-                        <p:par>
-                          <p:cTn id="215" fill="hold">
-                            <p:stCondLst>
-                              <p:cond delay="0"/>
-                            </p:stCondLst>
-                            <p:childTnLst>
-                              <p:par>
-                                <p:cTn id="216" presetID="1" presetClass="entr" fill="hold" nodeType="clickEffect">
-                                  <p:stCondLst>
-                                    <p:cond delay="0"/>
-                                  </p:stCondLst>
-                                  <p:childTnLst>
-                                    <p:set>
-                                      <p:cBhvr>
-                                        <p:cTn id="217" dur="1" fill="hold">
-                                          <p:stCondLst>
-                                            <p:cond delay="0"/>
-                                          </p:stCondLst>
-                                        </p:cTn>
-                                        <p:tgtEl>
-                                          <p:spTgt spid="82">
-                                            <p:txEl>
-                                              <p:pRg st="2" end="2"/>
-                                            </p:txEl>
-                                          </p:spTgt>
-                                        </p:tgtEl>
-                                        <p:attrNameLst>
-                                          <p:attrName>style.visibility</p:attrName>
-                                        </p:attrNameLst>
-                                      </p:cBhvr>
-                                      <p:to>
-                                        <p:strVal val="visible"/>
-                                      </p:to>
-                                    </p:set>
-                                  </p:childTnLst>
-                                </p:cTn>
-                              </p:par>
-                            </p:childTnLst>
-                          </p:cTn>
-                        </p:par>
-                      </p:childTnLst>
-                    </p:cTn>
-                  </p:par>
-                  <p:par>
-                    <p:cTn id="218" fill="hold">
-                      <p:stCondLst>
-                        <p:cond delay="indefinite"/>
-                      </p:stCondLst>
-                      <p:childTnLst>
-                        <p:par>
-                          <p:cTn id="219" fill="hold">
-                            <p:stCondLst>
-                              <p:cond delay="0"/>
-                            </p:stCondLst>
-                            <p:childTnLst>
-                              <p:par>
-                                <p:cTn id="220" presetID="1" presetClass="entr" fill="hold" nodeType="clickEffect">
-                                  <p:stCondLst>
-                                    <p:cond delay="0"/>
-                                  </p:stCondLst>
-                                  <p:childTnLst>
-                                    <p:set>
-                                      <p:cBhvr>
-                                        <p:cTn id="221" dur="1" fill="hold">
-                                          <p:stCondLst>
-                                            <p:cond delay="0"/>
-                                          </p:stCondLst>
-                                        </p:cTn>
-                                        <p:tgtEl>
-                                          <p:spTgt spid="82">
-                                            <p:txEl>
-                                              <p:pRg st="3" end="3"/>
-                                            </p:txEl>
-                                          </p:spTgt>
-                                        </p:tgtEl>
-                                        <p:attrNameLst>
-                                          <p:attrName>style.visibility</p:attrName>
-                                        </p:attrNameLst>
-                                      </p:cBhvr>
-                                      <p:to>
-                                        <p:strVal val="visible"/>
-                                      </p:to>
-                                    </p:set>
-                                  </p:childTnLst>
-                                </p:cTn>
-                              </p:par>
-                            </p:childTnLst>
-                          </p:cTn>
-                        </p:par>
-                      </p:childTnLst>
-                    </p:cTn>
-                  </p:par>
-                  <p:par>
-                    <p:cTn id="222" fill="hold">
-                      <p:stCondLst>
-                        <p:cond delay="indefinite"/>
-                      </p:stCondLst>
-                      <p:childTnLst>
-                        <p:par>
-                          <p:cTn id="223" fill="hold">
-                            <p:stCondLst>
-                              <p:cond delay="0"/>
-                            </p:stCondLst>
-                            <p:childTnLst>
-                              <p:par>
-                                <p:cTn id="224" presetID="1" presetClass="entr" fill="hold" nodeType="clickEffect">
-                                  <p:stCondLst>
-                                    <p:cond delay="0"/>
-                                  </p:stCondLst>
-                                  <p:childTnLst>
-                                    <p:set>
-                                      <p:cBhvr>
-                                        <p:cTn id="225" dur="1" fill="hold">
-                                          <p:stCondLst>
-                                            <p:cond delay="0"/>
-                                          </p:stCondLst>
-                                        </p:cTn>
-                                        <p:tgtEl>
-                                          <p:spTgt spid="82">
-                                            <p:txEl>
-                                              <p:pRg st="4" end="4"/>
-                                            </p:txEl>
-                                          </p:spTgt>
-                                        </p:tgtEl>
-                                        <p:attrNameLst>
-                                          <p:attrName>style.visibility</p:attrName>
-                                        </p:attrNameLst>
-                                      </p:cBhvr>
-                                      <p:to>
-                                        <p:strVal val="visible"/>
-                                      </p:to>
-                                    </p:set>
-                                  </p:childTnLst>
-                                </p:cTn>
-                              </p:par>
-                            </p:childTnLst>
-                          </p:cTn>
-                        </p:par>
-                      </p:childTnLst>
-                    </p:cTn>
-                  </p:par>
-                  <p:par>
-                    <p:cTn id="226" fill="hold">
-                      <p:stCondLst>
-                        <p:cond delay="indefinite"/>
-                      </p:stCondLst>
-                      <p:childTnLst>
-                        <p:par>
-                          <p:cTn id="227" fill="hold">
-                            <p:stCondLst>
-                              <p:cond delay="0"/>
-                            </p:stCondLst>
-                            <p:childTnLst>
-                              <p:par>
-                                <p:cTn id="228" presetID="1" presetClass="entr" fill="hold" nodeType="clickEffect">
-                                  <p:stCondLst>
-                                    <p:cond delay="0"/>
-                                  </p:stCondLst>
-                                  <p:childTnLst>
-                                    <p:set>
-                                      <p:cBhvr>
-                                        <p:cTn id="229" dur="1" fill="hold">
-                                          <p:stCondLst>
-                                            <p:cond delay="0"/>
-                                          </p:stCondLst>
-                                        </p:cTn>
-                                        <p:tgtEl>
-                                          <p:spTgt spid="82">
-                                            <p:txEl>
-                                              <p:pRg st="5" end="5"/>
                                             </p:txEl>
                                           </p:spTgt>
                                         </p:tgtEl>
@@ -11716,8 +11392,8 @@
         </p:nvSpPr>
         <p:spPr>
           <a:xfrm>
-            <a:off x="540000" y="269640"/>
-            <a:ext cx="8999640" cy="990360"/>
+            <a:off x="540000" y="269280"/>
+            <a:ext cx="8999280" cy="990720"/>
           </a:xfrm>
           <a:prstGeom prst="rect">
             <a:avLst/>
@@ -11776,7 +11452,7 @@
         <p:spPr>
           <a:xfrm>
             <a:off x="540000" y="1440000"/>
-            <a:ext cx="8999640" cy="3599640"/>
+            <a:ext cx="8999280" cy="3599280"/>
           </a:xfrm>
           <a:prstGeom prst="rect">
             <a:avLst/>
@@ -12090,7 +11766,7 @@
         <p:txBody>
           <a:bodyPr/>
           <a:p>
-            <a:fld id="{343191AF-1743-4BD7-B5E6-1BAC7B0ADE82}" type="slidenum">
+            <a:fld id="{B7576D01-B1DF-43AD-BA50-BC47918C1874}" type="slidenum">
               <a:t>9</a:t>
             </a:fld>
           </a:p>
@@ -12109,11 +11785,256 @@
   <p:timing>
     <p:tnLst>
       <p:par>
-        <p:cTn id="230" dur="indefinite" restart="never" nodeType="tmRoot">
+        <p:cTn id="210" dur="indefinite" restart="never" nodeType="tmRoot">
           <p:childTnLst>
             <p:seq>
-              <p:cTn id="231" dur="indefinite" nodeType="mainSeq">
+              <p:cTn id="211" dur="indefinite" nodeType="mainSeq">
                 <p:childTnLst>
+                  <p:par>
+                    <p:cTn id="212" fill="hold">
+                      <p:stCondLst>
+                        <p:cond delay="indefinite"/>
+                      </p:stCondLst>
+                      <p:childTnLst>
+                        <p:par>
+                          <p:cTn id="213" fill="hold">
+                            <p:stCondLst>
+                              <p:cond delay="0"/>
+                            </p:stCondLst>
+                            <p:childTnLst>
+                              <p:par>
+                                <p:cTn id="214" presetID="1" presetClass="entr" fill="hold" nodeType="clickEffect">
+                                  <p:stCondLst>
+                                    <p:cond delay="0"/>
+                                  </p:stCondLst>
+                                  <p:childTnLst>
+                                    <p:set>
+                                      <p:cBhvr>
+                                        <p:cTn id="215" dur="1" fill="hold">
+                                          <p:stCondLst>
+                                            <p:cond delay="0"/>
+                                          </p:stCondLst>
+                                        </p:cTn>
+                                        <p:tgtEl>
+                                          <p:spTgt spid="84">
+                                            <p:txEl>
+                                              <p:pRg st="0" end="0"/>
+                                            </p:txEl>
+                                          </p:spTgt>
+                                        </p:tgtEl>
+                                        <p:attrNameLst>
+                                          <p:attrName>style.visibility</p:attrName>
+                                        </p:attrNameLst>
+                                      </p:cBhvr>
+                                      <p:to>
+                                        <p:strVal val="visible"/>
+                                      </p:to>
+                                    </p:set>
+                                  </p:childTnLst>
+                                </p:cTn>
+                              </p:par>
+                            </p:childTnLst>
+                          </p:cTn>
+                        </p:par>
+                      </p:childTnLst>
+                    </p:cTn>
+                  </p:par>
+                  <p:par>
+                    <p:cTn id="216" fill="hold">
+                      <p:stCondLst>
+                        <p:cond delay="indefinite"/>
+                      </p:stCondLst>
+                      <p:childTnLst>
+                        <p:par>
+                          <p:cTn id="217" fill="hold">
+                            <p:stCondLst>
+                              <p:cond delay="0"/>
+                            </p:stCondLst>
+                            <p:childTnLst>
+                              <p:par>
+                                <p:cTn id="218" presetID="1" presetClass="entr" fill="hold" nodeType="clickEffect">
+                                  <p:stCondLst>
+                                    <p:cond delay="0"/>
+                                  </p:stCondLst>
+                                  <p:childTnLst>
+                                    <p:set>
+                                      <p:cBhvr>
+                                        <p:cTn id="219" dur="1" fill="hold">
+                                          <p:stCondLst>
+                                            <p:cond delay="0"/>
+                                          </p:stCondLst>
+                                        </p:cTn>
+                                        <p:tgtEl>
+                                          <p:spTgt spid="84">
+                                            <p:txEl>
+                                              <p:pRg st="1" end="1"/>
+                                            </p:txEl>
+                                          </p:spTgt>
+                                        </p:tgtEl>
+                                        <p:attrNameLst>
+                                          <p:attrName>style.visibility</p:attrName>
+                                        </p:attrNameLst>
+                                      </p:cBhvr>
+                                      <p:to>
+                                        <p:strVal val="visible"/>
+                                      </p:to>
+                                    </p:set>
+                                  </p:childTnLst>
+                                </p:cTn>
+                              </p:par>
+                            </p:childTnLst>
+                          </p:cTn>
+                        </p:par>
+                      </p:childTnLst>
+                    </p:cTn>
+                  </p:par>
+                  <p:par>
+                    <p:cTn id="220" fill="hold">
+                      <p:stCondLst>
+                        <p:cond delay="indefinite"/>
+                      </p:stCondLst>
+                      <p:childTnLst>
+                        <p:par>
+                          <p:cTn id="221" fill="hold">
+                            <p:stCondLst>
+                              <p:cond delay="0"/>
+                            </p:stCondLst>
+                            <p:childTnLst>
+                              <p:par>
+                                <p:cTn id="222" presetID="1" presetClass="entr" fill="hold" nodeType="clickEffect">
+                                  <p:stCondLst>
+                                    <p:cond delay="0"/>
+                                  </p:stCondLst>
+                                  <p:childTnLst>
+                                    <p:set>
+                                      <p:cBhvr>
+                                        <p:cTn id="223" dur="1" fill="hold">
+                                          <p:stCondLst>
+                                            <p:cond delay="0"/>
+                                          </p:stCondLst>
+                                        </p:cTn>
+                                        <p:tgtEl>
+                                          <p:spTgt spid="84">
+                                            <p:txEl>
+                                              <p:pRg st="2" end="2"/>
+                                            </p:txEl>
+                                          </p:spTgt>
+                                        </p:tgtEl>
+                                        <p:attrNameLst>
+                                          <p:attrName>style.visibility</p:attrName>
+                                        </p:attrNameLst>
+                                      </p:cBhvr>
+                                      <p:to>
+                                        <p:strVal val="visible"/>
+                                      </p:to>
+                                    </p:set>
+                                  </p:childTnLst>
+                                </p:cTn>
+                              </p:par>
+                            </p:childTnLst>
+                          </p:cTn>
+                        </p:par>
+                      </p:childTnLst>
+                    </p:cTn>
+                  </p:par>
+                  <p:par>
+                    <p:cTn id="224" fill="hold">
+                      <p:stCondLst>
+                        <p:cond delay="indefinite"/>
+                      </p:stCondLst>
+                      <p:childTnLst>
+                        <p:par>
+                          <p:cTn id="225" fill="hold">
+                            <p:stCondLst>
+                              <p:cond delay="0"/>
+                            </p:stCondLst>
+                            <p:childTnLst>
+                              <p:par>
+                                <p:cTn id="226" presetID="1" presetClass="entr" fill="hold" nodeType="clickEffect">
+                                  <p:stCondLst>
+                                    <p:cond delay="0"/>
+                                  </p:stCondLst>
+                                  <p:childTnLst>
+                                    <p:set>
+                                      <p:cBhvr>
+                                        <p:cTn id="227" dur="1" fill="hold">
+                                          <p:stCondLst>
+                                            <p:cond delay="0"/>
+                                          </p:stCondLst>
+                                        </p:cTn>
+                                        <p:tgtEl>
+                                          <p:spTgt spid="84">
+                                            <p:txEl>
+                                              <p:pRg st="3" end="3"/>
+                                            </p:txEl>
+                                          </p:spTgt>
+                                        </p:tgtEl>
+                                        <p:attrNameLst>
+                                          <p:attrName>style.visibility</p:attrName>
+                                        </p:attrNameLst>
+                                      </p:cBhvr>
+                                      <p:to>
+                                        <p:strVal val="visible"/>
+                                      </p:to>
+                                    </p:set>
+                                  </p:childTnLst>
+                                </p:cTn>
+                              </p:par>
+                            </p:childTnLst>
+                          </p:cTn>
+                        </p:par>
+                      </p:childTnLst>
+                    </p:cTn>
+                  </p:par>
+                  <p:par>
+                    <p:cTn id="228" fill="hold">
+                      <p:stCondLst>
+                        <p:cond delay="indefinite"/>
+                      </p:stCondLst>
+                      <p:childTnLst>
+                        <p:par>
+                          <p:cTn id="229" fill="hold">
+                            <p:stCondLst>
+                              <p:cond delay="0"/>
+                            </p:stCondLst>
+                            <p:childTnLst>
+                              <p:par>
+                                <p:cTn id="230" presetID="1" presetClass="entr" fill="hold" nodeType="clickEffect">
+                                  <p:stCondLst>
+                                    <p:cond delay="0"/>
+                                  </p:stCondLst>
+                                  <p:childTnLst>
+                                    <p:set>
+                                      <p:cBhvr>
+                                        <p:cTn id="231" dur="1" fill="hold">
+                                          <p:stCondLst>
+                                            <p:cond delay="0"/>
+                                          </p:stCondLst>
+                                        </p:cTn>
+                                        <p:tgtEl>
+                                          <p:spTgt spid="84">
+                                            <p:txEl>
+                                              <p:pRg st="4" end="4"/>
+                                            </p:txEl>
+                                          </p:spTgt>
+                                        </p:tgtEl>
+                                        <p:attrNameLst>
+                                          <p:attrName>style.visibility</p:attrName>
+                                        </p:attrNameLst>
+                                      </p:cBhvr>
+                                      <p:to>
+                                        <p:strVal val="visible"/>
+                                      </p:to>
+                                    </p:set>
+                                  </p:childTnLst>
+                                </p:cTn>
+                              </p:par>
+                            </p:childTnLst>
+                          </p:cTn>
+                        </p:par>
+                      </p:childTnLst>
+                    </p:cTn>
+                  </p:par>
                   <p:par>
                     <p:cTn id="232" fill="hold">
                       <p:stCondLst>
@@ -12142,7 +12063,7 @@
                                         <p:tgtEl>
                                           <p:spTgt spid="84">
                                             <p:txEl>
-                                              <p:pRg st="0" end="0"/>
+                                              <p:pRg st="5" end="5"/>
                                             </p:txEl>
                                           </p:spTgt>
                                         </p:tgtEl>
@@ -12191,7 +12112,7 @@
                                         <p:tgtEl>
                                           <p:spTgt spid="84">
                                             <p:txEl>
-                                              <p:pRg st="1" end="1"/>
+                                              <p:pRg st="6" end="6"/>
                                             </p:txEl>
                                           </p:spTgt>
                                         </p:tgtEl>
@@ -12233,251 +12154,6 @@
                                     <p:set>
                                       <p:cBhvr>
                                         <p:cTn id="243" dur="1" fill="hold">
-                                          <p:stCondLst>
-                                            <p:cond delay="0"/>
-                                          </p:stCondLst>
-                                        </p:cTn>
-                                        <p:tgtEl>
-                                          <p:spTgt spid="84">
-                                            <p:txEl>
-                                              <p:pRg st="2" end="2"/>
-                                            </p:txEl>
-                                          </p:spTgt>
-                                        </p:tgtEl>
-                                        <p:attrNameLst>
-                                          <p:attrName>style.visibility</p:attrName>
-                                        </p:attrNameLst>
-                                      </p:cBhvr>
-                                      <p:to>
-                                        <p:strVal val="visible"/>
-                                      </p:to>
-                                    </p:set>
-                                  </p:childTnLst>
-                                </p:cTn>
-                              </p:par>
-                            </p:childTnLst>
-                          </p:cTn>
-                        </p:par>
-                      </p:childTnLst>
-                    </p:cTn>
-                  </p:par>
-                  <p:par>
-                    <p:cTn id="244" fill="hold">
-                      <p:stCondLst>
-                        <p:cond delay="indefinite"/>
-                      </p:stCondLst>
-                      <p:childTnLst>
-                        <p:par>
-                          <p:cTn id="245" fill="hold">
-                            <p:stCondLst>
-                              <p:cond delay="0"/>
-                            </p:stCondLst>
-                            <p:childTnLst>
-                              <p:par>
-                                <p:cTn id="246" presetID="1" presetClass="entr" fill="hold" nodeType="clickEffect">
-                                  <p:stCondLst>
-                                    <p:cond delay="0"/>
-                                  </p:stCondLst>
-                                  <p:childTnLst>
-                                    <p:set>
-                                      <p:cBhvr>
-                                        <p:cTn id="247" dur="1" fill="hold">
-                                          <p:stCondLst>
-                                            <p:cond delay="0"/>
-                                          </p:stCondLst>
-                                        </p:cTn>
-                                        <p:tgtEl>
-                                          <p:spTgt spid="84">
-                                            <p:txEl>
-                                              <p:pRg st="3" end="3"/>
-                                            </p:txEl>
-                                          </p:spTgt>
-                                        </p:tgtEl>
-                                        <p:attrNameLst>
-                                          <p:attrName>style.visibility</p:attrName>
-                                        </p:attrNameLst>
-                                      </p:cBhvr>
-                                      <p:to>
-                                        <p:strVal val="visible"/>
-                                      </p:to>
-                                    </p:set>
-                                  </p:childTnLst>
-                                </p:cTn>
-                              </p:par>
-                            </p:childTnLst>
-                          </p:cTn>
-                        </p:par>
-                      </p:childTnLst>
-                    </p:cTn>
-                  </p:par>
-                  <p:par>
-                    <p:cTn id="248" fill="hold">
-                      <p:stCondLst>
-                        <p:cond delay="indefinite"/>
-                      </p:stCondLst>
-                      <p:childTnLst>
-                        <p:par>
-                          <p:cTn id="249" fill="hold">
-                            <p:stCondLst>
-                              <p:cond delay="0"/>
-                            </p:stCondLst>
-                            <p:childTnLst>
-                              <p:par>
-                                <p:cTn id="250" presetID="1" presetClass="entr" fill="hold" nodeType="clickEffect">
-                                  <p:stCondLst>
-                                    <p:cond delay="0"/>
-                                  </p:stCondLst>
-                                  <p:childTnLst>
-                                    <p:set>
-                                      <p:cBhvr>
-                                        <p:cTn id="251" dur="1" fill="hold">
-                                          <p:stCondLst>
-                                            <p:cond delay="0"/>
-                                          </p:stCondLst>
-                                        </p:cTn>
-                                        <p:tgtEl>
-                                          <p:spTgt spid="84">
-                                            <p:txEl>
-                                              <p:pRg st="4" end="4"/>
-                                            </p:txEl>
-                                          </p:spTgt>
-                                        </p:tgtEl>
-                                        <p:attrNameLst>
-                                          <p:attrName>style.visibility</p:attrName>
-                                        </p:attrNameLst>
-                                      </p:cBhvr>
-                                      <p:to>
-                                        <p:strVal val="visible"/>
-                                      </p:to>
-                                    </p:set>
-                                  </p:childTnLst>
-                                </p:cTn>
-                              </p:par>
-                            </p:childTnLst>
-                          </p:cTn>
-                        </p:par>
-                      </p:childTnLst>
-                    </p:cTn>
-                  </p:par>
-                  <p:par>
-                    <p:cTn id="252" fill="hold">
-                      <p:stCondLst>
-                        <p:cond delay="indefinite"/>
-                      </p:stCondLst>
-                      <p:childTnLst>
-                        <p:par>
-                          <p:cTn id="253" fill="hold">
-                            <p:stCondLst>
-                              <p:cond delay="0"/>
-                            </p:stCondLst>
-                            <p:childTnLst>
-                              <p:par>
-                                <p:cTn id="254" presetID="1" presetClass="entr" fill="hold" nodeType="clickEffect">
-                                  <p:stCondLst>
-                                    <p:cond delay="0"/>
-                                  </p:stCondLst>
-                                  <p:childTnLst>
-                                    <p:set>
-                                      <p:cBhvr>
-                                        <p:cTn id="255" dur="1" fill="hold">
-                                          <p:stCondLst>
-                                            <p:cond delay="0"/>
-                                          </p:stCondLst>
-                                        </p:cTn>
-                                        <p:tgtEl>
-                                          <p:spTgt spid="84">
-                                            <p:txEl>
-                                              <p:pRg st="5" end="5"/>
-                                            </p:txEl>
-                                          </p:spTgt>
-                                        </p:tgtEl>
-                                        <p:attrNameLst>
-                                          <p:attrName>style.visibility</p:attrName>
-                                        </p:attrNameLst>
-                                      </p:cBhvr>
-                                      <p:to>
-                                        <p:strVal val="visible"/>
-                                      </p:to>
-                                    </p:set>
-                                  </p:childTnLst>
-                                </p:cTn>
-                              </p:par>
-                            </p:childTnLst>
-                          </p:cTn>
-                        </p:par>
-                      </p:childTnLst>
-                    </p:cTn>
-                  </p:par>
-                  <p:par>
-                    <p:cTn id="256" fill="hold">
-                      <p:stCondLst>
-                        <p:cond delay="indefinite"/>
-                      </p:stCondLst>
-                      <p:childTnLst>
-                        <p:par>
-                          <p:cTn id="257" fill="hold">
-                            <p:stCondLst>
-                              <p:cond delay="0"/>
-                            </p:stCondLst>
-                            <p:childTnLst>
-                              <p:par>
-                                <p:cTn id="258" presetID="1" presetClass="entr" fill="hold" nodeType="clickEffect">
-                                  <p:stCondLst>
-                                    <p:cond delay="0"/>
-                                  </p:stCondLst>
-                                  <p:childTnLst>
-                                    <p:set>
-                                      <p:cBhvr>
-                                        <p:cTn id="259" dur="1" fill="hold">
-                                          <p:stCondLst>
-                                            <p:cond delay="0"/>
-                                          </p:stCondLst>
-                                        </p:cTn>
-                                        <p:tgtEl>
-                                          <p:spTgt spid="84">
-                                            <p:txEl>
-                                              <p:pRg st="6" end="6"/>
-                                            </p:txEl>
-                                          </p:spTgt>
-                                        </p:tgtEl>
-                                        <p:attrNameLst>
-                                          <p:attrName>style.visibility</p:attrName>
-                                        </p:attrNameLst>
-                                      </p:cBhvr>
-                                      <p:to>
-                                        <p:strVal val="visible"/>
-                                      </p:to>
-                                    </p:set>
-                                  </p:childTnLst>
-                                </p:cTn>
-                              </p:par>
-                            </p:childTnLst>
-                          </p:cTn>
-                        </p:par>
-                      </p:childTnLst>
-                    </p:cTn>
-                  </p:par>
-                  <p:par>
-                    <p:cTn id="260" fill="hold">
-                      <p:stCondLst>
-                        <p:cond delay="indefinite"/>
-                      </p:stCondLst>
-                      <p:childTnLst>
-                        <p:par>
-                          <p:cTn id="261" fill="hold">
-                            <p:stCondLst>
-                              <p:cond delay="0"/>
-                            </p:stCondLst>
-                            <p:childTnLst>
-                              <p:par>
-                                <p:cTn id="262" presetID="1" presetClass="entr" fill="hold" nodeType="clickEffect">
-                                  <p:stCondLst>
-                                    <p:cond delay="0"/>
-                                  </p:stCondLst>
-                                  <p:childTnLst>
-                                    <p:set>
-                                      <p:cBhvr>
-                                        <p:cTn id="263" dur="1" fill="hold">
                                           <p:stCondLst>
                                             <p:cond delay="0"/>
                                           </p:stCondLst>

</xml_diff>